<commit_message>
sd-11-013: name step 5 vertical scaling, rebuild slide 9 without duplicates
Co-Authored-By: Claude Sonnet 5.5 <noreply@anthropic.com>
Claude-Session: https://claude.ai/code/session_0121Z35eF2EmPsW9asDgHWsZ
</commit_message>
<xml_diff>
--- a/system-design-101/vi/lessons/sd-11-013/slides/sd-11-013.pptx
+++ b/system-design-101/vi/lessons/sd-11-013/slides/sd-11-013.pptx
@@ -7015,7 +7015,7 @@
               <a:buNone/>
             </a:pPr>
             <a:r>
-              <a:rPr lang="en-US" sz="3300" dirty="0" spc="2" kern="0">
+              <a:rPr lang="en-US" sz="3000" dirty="0" spc="-51" kern="0">
                 <a:solidFill>
                   <a:srgbClr val="FF6A4D"/>
                 </a:solidFill>
@@ -7023,10 +7023,10 @@
                 <a:ea typeface="Bricolage Grotesque ExtraBold" pitchFamily="34" charset="-122"/>
                 <a:cs typeface="Bricolage Grotesque ExtraBold" pitchFamily="34" charset="-120"/>
               </a:rPr>
-              <a:t>Chiều</a:t>
-            </a:r>
-            <a:r>
-              <a:rPr lang="en-US" sz="3300" dirty="0" spc="-1" kern="0">
+              <a:t>Tăng</a:t>
+            </a:r>
+            <a:r>
+              <a:rPr lang="en-US" sz="3000" dirty="0" spc="0" kern="0">
                 <a:solidFill>
                   <a:srgbClr val="FF6A4D"/>
                 </a:solidFill>
@@ -7034,9 +7034,20 @@
                 <a:ea typeface="Bricolage Grotesque ExtraBold" pitchFamily="34" charset="-122"/>
                 <a:cs typeface="Bricolage Grotesque ExtraBold" pitchFamily="34" charset="-120"/>
               </a:rPr>
-              <a:t> dọc</a:t>
-            </a:r>
-            <a:endParaRPr lang="en-US" sz="3300" dirty="0"/>
+              <a:t> cấu</a:t>
+            </a:r>
+            <a:r>
+              <a:rPr lang="en-US" sz="3000" dirty="0" spc="-7" kern="0">
+                <a:solidFill>
+                  <a:srgbClr val="FF6A4D"/>
+                </a:solidFill>
+                <a:latin typeface="Bricolage Grotesque ExtraBold" pitchFamily="34" charset="0"/>
+                <a:ea typeface="Bricolage Grotesque ExtraBold" pitchFamily="34" charset="-122"/>
+                <a:cs typeface="Bricolage Grotesque ExtraBold" pitchFamily="34" charset="-120"/>
+              </a:rPr>
+              <a:t> hình</a:t>
+            </a:r>
+            <a:endParaRPr lang="en-US" sz="3000" dirty="0"/>
           </a:p>
         </p:txBody>
       </p:sp>
@@ -7076,10 +7087,10 @@
                 <a:ea typeface="Be Vietnam Pro" pitchFamily="34" charset="-122"/>
                 <a:cs typeface="Be Vietnam Pro" pitchFamily="34" charset="-120"/>
               </a:rPr>
-              <a:t>Thêm</a:t>
-            </a:r>
-            <a:r>
-              <a:rPr lang="en-US" sz="2550" dirty="0" spc="7" kern="0">
+              <a:t>Thêm CPU,</a:t>
+            </a:r>
+            <a:r>
+              <a:rPr lang="en-US" sz="2550" dirty="0" spc="1" kern="0">
                 <a:solidFill>
                   <a:srgbClr val="F3EEE3"/>
                 </a:solidFill>
@@ -7087,7 +7098,7 @@
                 <a:ea typeface="Be Vietnam Pro" pitchFamily="34" charset="-122"/>
                 <a:cs typeface="Be Vietnam Pro" pitchFamily="34" charset="-120"/>
               </a:rPr>
-              <a:t> sức</a:t>
+              <a:t> RAM</a:t>
             </a:r>
             <a:r>
               <a:rPr lang="en-US" sz="2550" dirty="0" spc="0" kern="0">
@@ -7098,7 +7109,7 @@
                 <a:ea typeface="Be Vietnam Pro" pitchFamily="34" charset="-122"/>
                 <a:cs typeface="Be Vietnam Pro" pitchFamily="34" charset="-120"/>
               </a:rPr>
-              <a:t> mạnh</a:t>
+              <a:t> cho</a:t>
             </a:r>
             <a:r>
               <a:rPr lang="en-US" sz="2550" dirty="0" spc="-5" kern="0">
@@ -7112,7 +7123,7 @@
               <a:t> một</a:t>
             </a:r>
             <a:r>
-              <a:rPr lang="en-US" sz="2550" dirty="0" spc="-7" kern="0">
+              <a:rPr lang="en-US" sz="2550" dirty="0" spc="-9" kern="0">
                 <a:solidFill>
                   <a:srgbClr val="F3EEE3"/>
                 </a:solidFill>
@@ -7120,10 +7131,10 @@
                 <a:ea typeface="Be Vietnam Pro" pitchFamily="34" charset="-122"/>
                 <a:cs typeface="Be Vietnam Pro" pitchFamily="34" charset="-120"/>
               </a:rPr>
-              <a:t> máy,</a:t>
-            </a:r>
-            <a:r>
-              <a:rPr lang="en-US" sz="2550" dirty="0" spc="-1" kern="0">
+              <a:t> máy</a:t>
+            </a:r>
+            <a:r>
+              <a:rPr lang="en-US" sz="2550" dirty="0" spc="-6" kern="0">
                 <a:solidFill>
                   <a:srgbClr val="F3EEE3"/>
                 </a:solidFill>
@@ -7131,7 +7142,18 @@
                 <a:ea typeface="Be Vietnam Pro" pitchFamily="34" charset="-122"/>
                 <a:cs typeface="Be Vietnam Pro" pitchFamily="34" charset="-120"/>
               </a:rPr>
-              <a:t> có</a:t>
+              <a:t> (vertical</a:t>
+            </a:r>
+            <a:r>
+              <a:rPr lang="en-US" sz="2550" dirty="0" spc="-4" kern="0">
+                <a:solidFill>
+                  <a:srgbClr val="F3EEE3"/>
+                </a:solidFill>
+                <a:latin typeface="Be Vietnam Pro" pitchFamily="34" charset="0"/>
+                <a:ea typeface="Be Vietnam Pro" pitchFamily="34" charset="-122"/>
+                <a:cs typeface="Be Vietnam Pro" pitchFamily="34" charset="-120"/>
+              </a:rPr>
+              <a:t> scaling),</a:t>
             </a:r>
             <a:r>
               <a:rPr lang="en-US" sz="2550" dirty="0" spc="0" kern="0">
@@ -7142,7 +7164,7 @@
                 <a:ea typeface="Be Vietnam Pro" pitchFamily="34" charset="-122"/>
                 <a:cs typeface="Be Vietnam Pro" pitchFamily="34" charset="-120"/>
               </a:rPr>
-              <a:t> giới</a:t>
+              <a:t> có giới</a:t>
             </a:r>
             <a:r>
               <a:rPr lang="en-US" sz="2550" dirty="0" spc="-1" kern="0">
@@ -7311,7 +7333,62 @@
                 <a:ea typeface="Be Vietnam Pro" pitchFamily="34" charset="-122"/>
                 <a:cs typeface="Be Vietnam Pro" pitchFamily="34" charset="-120"/>
               </a:rPr>
-              <a:t> liệu</a:t>
+              <a:t> liệu,</a:t>
+            </a:r>
+            <a:r>
+              <a:rPr lang="en-US" sz="2550" dirty="0" spc="0" kern="0">
+                <a:solidFill>
+                  <a:srgbClr val="F3EEE3"/>
+                </a:solidFill>
+                <a:latin typeface="Be Vietnam Pro" pitchFamily="34" charset="0"/>
+                <a:ea typeface="Be Vietnam Pro" pitchFamily="34" charset="-122"/>
+                <a:cs typeface="Be Vietnam Pro" pitchFamily="34" charset="-120"/>
+              </a:rPr>
+              <a:t> mỗi</a:t>
+            </a:r>
+            <a:r>
+              <a:rPr lang="en-US" sz="2550" dirty="0" spc="-9" kern="0">
+                <a:solidFill>
+                  <a:srgbClr val="F3EEE3"/>
+                </a:solidFill>
+                <a:latin typeface="Be Vietnam Pro" pitchFamily="34" charset="0"/>
+                <a:ea typeface="Be Vietnam Pro" pitchFamily="34" charset="-122"/>
+                <a:cs typeface="Be Vietnam Pro" pitchFamily="34" charset="-120"/>
+              </a:rPr>
+              <a:t> máy</a:t>
+            </a:r>
+            <a:r>
+              <a:rPr lang="en-US" sz="2550" dirty="0" spc="-2" kern="0">
+                <a:solidFill>
+                  <a:srgbClr val="F3EEE3"/>
+                </a:solidFill>
+                <a:latin typeface="Be Vietnam Pro" pitchFamily="34" charset="0"/>
+                <a:ea typeface="Be Vietnam Pro" pitchFamily="34" charset="-122"/>
+                <a:cs typeface="Be Vietnam Pro" pitchFamily="34" charset="-120"/>
+              </a:rPr>
+              <a:t> giữ</a:t>
+            </a:r>
+            <a:r>
+              <a:rPr lang="en-US" sz="2550" dirty="0" spc="-5" kern="0">
+                <a:solidFill>
+                  <a:srgbClr val="F3EEE3"/>
+                </a:solidFill>
+                <a:latin typeface="Be Vietnam Pro" pitchFamily="34" charset="0"/>
+                <a:ea typeface="Be Vietnam Pro" pitchFamily="34" charset="-122"/>
+                <a:cs typeface="Be Vietnam Pro" pitchFamily="34" charset="-120"/>
+              </a:rPr>
+              <a:t> một</a:t>
+            </a:r>
+            <a:r>
+              <a:rPr lang="en-US" sz="2550" dirty="0" spc="0" kern="0">
+                <a:solidFill>
+                  <a:srgbClr val="F3EEE3"/>
+                </a:solidFill>
+                <a:latin typeface="Be Vietnam Pro" pitchFamily="34" charset="0"/>
+                <a:ea typeface="Be Vietnam Pro" pitchFamily="34" charset="-122"/>
+                <a:cs typeface="Be Vietnam Pro" pitchFamily="34" charset="-120"/>
+              </a:rPr>
+              <a:t> phần</a:t>
             </a:r>
             <a:endParaRPr lang="en-US" sz="2550" dirty="0"/>
           </a:p>
@@ -9325,7 +9402,7 @@
               <a:buNone/>
             </a:pPr>
             <a:r>
-              <a:rPr lang="en-US" sz="2850" b="1" dirty="0" spc="0" kern="0">
+              <a:rPr lang="en-US" sz="2850" b="1" dirty="0" spc="4" kern="0">
                 <a:solidFill>
                   <a:srgbClr val="F3EEE3"/>
                 </a:solidFill>
@@ -9333,10 +9410,10 @@
                 <a:ea typeface="Be Vietnam Pro" pitchFamily="34" charset="-122"/>
                 <a:cs typeface="Be Vietnam Pro" pitchFamily="34" charset="-120"/>
               </a:rPr>
-              <a:t>"Chia</a:t>
-            </a:r>
-            <a:r>
-              <a:rPr lang="en-US" sz="2850" b="1" dirty="0" spc="-6" kern="0">
+              <a:t>Bài</a:t>
+            </a:r>
+            <a:r>
+              <a:rPr lang="en-US" sz="2850" b="1" dirty="0" spc="-3" kern="0">
                 <a:solidFill>
                   <a:srgbClr val="F3EEE3"/>
                 </a:solidFill>
@@ -9344,10 +9421,10 @@
                 <a:ea typeface="Be Vietnam Pro" pitchFamily="34" charset="-122"/>
                 <a:cs typeface="Be Vietnam Pro" pitchFamily="34" charset="-120"/>
               </a:rPr>
-              <a:t> theo</a:t>
-            </a:r>
-            <a:r>
-              <a:rPr lang="en-US" sz="2850" b="1" dirty="0" spc="2" kern="0">
+              <a:t> nguồn</a:t>
+            </a:r>
+            <a:r>
+              <a:rPr lang="en-US" sz="2850" b="1" dirty="0" spc="-1" kern="0">
                 <a:solidFill>
                   <a:srgbClr val="F3EEE3"/>
                 </a:solidFill>
@@ -9355,10 +9432,10 @@
                 <a:ea typeface="Be Vietnam Pro" pitchFamily="34" charset="-122"/>
                 <a:cs typeface="Be Vietnam Pro" pitchFamily="34" charset="-120"/>
               </a:rPr>
-              <a:t> chiều</a:t>
-            </a:r>
-            <a:r>
-              <a:rPr lang="en-US" sz="2850" b="1" dirty="0" spc="-3" kern="0">
+              <a:t> gọi</a:t>
+            </a:r>
+            <a:r>
+              <a:rPr lang="en-US" sz="2850" b="1" dirty="0" spc="-4" kern="0">
                 <a:solidFill>
                   <a:srgbClr val="F3EEE3"/>
                 </a:solidFill>
@@ -9366,10 +9443,10 @@
                 <a:ea typeface="Be Vietnam Pro" pitchFamily="34" charset="-122"/>
                 <a:cs typeface="Be Vietnam Pro" pitchFamily="34" charset="-120"/>
               </a:rPr>
-              <a:t> dọc"</a:t>
-            </a:r>
-            <a:r>
-              <a:rPr lang="en-US" sz="2850" b="1" dirty="0" spc="2" kern="0">
+              <a:t> tăng</a:t>
+            </a:r>
+            <a:r>
+              <a:rPr lang="en-US" sz="2850" b="1" dirty="0" spc="4" kern="0">
                 <a:solidFill>
                   <a:srgbClr val="F3EEE3"/>
                 </a:solidFill>
@@ -9377,7 +9454,7 @@
                 <a:ea typeface="Be Vietnam Pro" pitchFamily="34" charset="-122"/>
                 <a:cs typeface="Be Vietnam Pro" pitchFamily="34" charset="-120"/>
               </a:rPr>
-              <a:t> ở</a:t>
+              <a:t> cấu</a:t>
             </a:r>
             <a:r>
               <a:rPr lang="en-US" sz="2850" b="1" dirty="0" spc="-1" kern="0">
@@ -9388,7 +9465,7 @@
                 <a:ea typeface="Be Vietnam Pro" pitchFamily="34" charset="-122"/>
                 <a:cs typeface="Be Vietnam Pro" pitchFamily="34" charset="-120"/>
               </a:rPr>
-              <a:t> đây</a:t>
+              <a:t> hình</a:t>
             </a:r>
             <a:r>
               <a:rPr lang="en-US" sz="2850" b="1" dirty="0" spc="-4" kern="0">
@@ -9399,10 +9476,10 @@
                 <a:ea typeface="Be Vietnam Pro" pitchFamily="34" charset="-122"/>
                 <a:cs typeface="Be Vietnam Pro" pitchFamily="34" charset="-120"/>
               </a:rPr>
-              <a:t> là tăng</a:t>
-            </a:r>
-            <a:r>
-              <a:rPr lang="en-US" sz="2850" b="1" dirty="0" spc="4" kern="0">
+              <a:t> là</a:t>
+            </a:r>
+            <a:r>
+              <a:rPr lang="en-US" sz="2850" b="1" dirty="0" spc="-5" kern="0">
                 <a:solidFill>
                   <a:srgbClr val="F3EEE3"/>
                 </a:solidFill>
@@ -9410,10 +9487,10 @@
                 <a:ea typeface="Be Vietnam Pro" pitchFamily="34" charset="-122"/>
                 <a:cs typeface="Be Vietnam Pro" pitchFamily="34" charset="-120"/>
               </a:rPr>
-              <a:t> cấu</a:t>
-            </a:r>
-            <a:r>
-              <a:rPr lang="en-US" sz="2850" b="1" dirty="0" spc="-1" kern="0">
+              <a:t> "vertical</a:t>
+            </a:r>
+            <a:r>
+              <a:rPr lang="en-US" sz="2850" b="1" dirty="0" spc="1" kern="0">
                 <a:solidFill>
                   <a:srgbClr val="F3EEE3"/>
                 </a:solidFill>
@@ -9421,18 +9498,7 @@
                 <a:ea typeface="Be Vietnam Pro" pitchFamily="34" charset="-122"/>
                 <a:cs typeface="Be Vietnam Pro" pitchFamily="34" charset="-120"/>
               </a:rPr>
-              <a:t> hình</a:t>
-            </a:r>
-            <a:r>
-              <a:rPr lang="en-US" sz="2850" b="1" dirty="0" spc="-9" kern="0">
-                <a:solidFill>
-                  <a:srgbClr val="F3EEE3"/>
-                </a:solidFill>
-                <a:latin typeface="Be Vietnam Pro" pitchFamily="34" charset="0"/>
-                <a:ea typeface="Be Vietnam Pro" pitchFamily="34" charset="-122"/>
-                <a:cs typeface="Be Vietnam Pro" pitchFamily="34" charset="-120"/>
-              </a:rPr>
-              <a:t> máy</a:t>
+              <a:t> partition"</a:t>
             </a:r>
             <a:endParaRPr lang="en-US" sz="2850" dirty="0"/>
           </a:p>
@@ -11475,14 +11541,14 @@
       </p:sp>
       <p:sp>
         <p:nvSpPr>
-          <p:cNvPr id="4" name="Connector line-1792422977098-410624087"/>
-          <p:cNvSpPr/>
-          <p:nvPr/>
-        </p:nvSpPr>
-        <p:spPr>
-          <a:xfrm>
-            <a:off x="1905000" y="4953000"/>
-            <a:ext cx="14478000" cy="0"/>
+          <p:cNvPr id="4" name="Connector line-1792424475648-782606762"/>
+          <p:cNvSpPr/>
+          <p:nvPr/>
+        </p:nvSpPr>
+        <p:spPr>
+          <a:xfrm>
+            <a:off x="1428750" y="4953000"/>
+            <a:ext cx="15430500" cy="0"/>
           </a:xfrm>
           <a:prstGeom prst="line">
             <a:avLst/>
@@ -12250,929 +12316,7 @@
       </p:sp>
       <p:sp>
         <p:nvSpPr>
-          <p:cNvPr id="22" name="Text 20"/>
-          <p:cNvSpPr/>
-          <p:nvPr/>
-        </p:nvSpPr>
-        <p:spPr>
-          <a:xfrm>
-            <a:off x="914400" y="952500"/>
-            <a:ext cx="14287500" cy="323850"/>
-          </a:xfrm>
-          <a:prstGeom prst="rect">
-            <a:avLst/>
-          </a:prstGeom>
-          <a:noFill/>
-          <a:ln/>
-        </p:spPr>
-        <p:txBody>
-          <a:bodyPr wrap="square" lIns="0" tIns="0" rIns="0" bIns="0" rtlCol="0" anchor="t"/>
-          <a:lstStyle/>
-          <a:p>
-            <a:pPr algn="l" indent="0" marL="0">
-              <a:buNone/>
-            </a:pPr>
-            <a:r>
-              <a:rPr lang="en-US" sz="1800" b="1" spc="300" kern="0" dirty="0">
-                <a:solidFill>
-                  <a:srgbClr val="6B6A66"/>
-                </a:solidFill>
-                <a:latin typeface="Be Vietnam Pro" pitchFamily="34" charset="0"/>
-                <a:ea typeface="Be Vietnam Pro" pitchFamily="34" charset="-122"/>
-                <a:cs typeface="Be Vietnam Pro" pitchFamily="34" charset="-120"/>
-              </a:rPr>
-              <a:t>XEM</a:t>
-            </a:r>
-            <a:r>
-              <a:rPr lang="en-US" sz="1800" b="1" spc="289" kern="0" dirty="0">
-                <a:solidFill>
-                  <a:srgbClr val="6B6A66"/>
-                </a:solidFill>
-                <a:latin typeface="Be Vietnam Pro" pitchFamily="34" charset="0"/>
-                <a:ea typeface="Be Vietnam Pro" pitchFamily="34" charset="-122"/>
-                <a:cs typeface="Be Vietnam Pro" pitchFamily="34" charset="-120"/>
-              </a:rPr>
-              <a:t> SÂU</a:t>
-            </a:r>
-            <a:r>
-              <a:rPr lang="en-US" sz="1800" b="1" spc="301" kern="0" dirty="0">
-                <a:solidFill>
-                  <a:srgbClr val="6B6A66"/>
-                </a:solidFill>
-                <a:latin typeface="Be Vietnam Pro" pitchFamily="34" charset="0"/>
-                <a:ea typeface="Be Vietnam Pro" pitchFamily="34" charset="-122"/>
-                <a:cs typeface="Be Vietnam Pro" pitchFamily="34" charset="-120"/>
-              </a:rPr>
-              <a:t> HƠN</a:t>
-            </a:r>
-            <a:endParaRPr lang="en-US" sz="1800" dirty="0"/>
-          </a:p>
-        </p:txBody>
-      </p:sp>
-      <p:sp>
-        <p:nvSpPr>
-          <p:cNvPr id="23" name="Text 21"/>
-          <p:cNvSpPr/>
-          <p:nvPr/>
-        </p:nvSpPr>
-        <p:spPr>
-          <a:xfrm>
-            <a:off x="914400" y="1333500"/>
-            <a:ext cx="16459200" cy="1066800"/>
-          </a:xfrm>
-          <a:prstGeom prst="rect">
-            <a:avLst/>
-          </a:prstGeom>
-          <a:noFill/>
-          <a:ln/>
-        </p:spPr>
-        <p:txBody>
-          <a:bodyPr wrap="square" lIns="0" tIns="59150" rIns="0" bIns="-59150" rtlCol="0" anchor="ctr"/>
-          <a:lstStyle/>
-          <a:p>
-            <a:pPr algn="l" indent="0" marL="0">
-              <a:lnSpc>
-                <a:spcPts val="7245"/>
-              </a:lnSpc>
-              <a:buNone/>
-            </a:pPr>
-            <a:r>
-              <a:rPr lang="en-US" sz="6900" dirty="0" spc="12" kern="0">
-                <a:solidFill>
-                  <a:srgbClr val="14161C"/>
-                </a:solidFill>
-                <a:latin typeface="Bricolage Grotesque ExtraBold" pitchFamily="34" charset="0"/>
-                <a:ea typeface="Bricolage Grotesque ExtraBold" pitchFamily="34" charset="-122"/>
-                <a:cs typeface="Bricolage Grotesque ExtraBold" pitchFamily="34" charset="-120"/>
-              </a:rPr>
-              <a:t>Điều</a:t>
-            </a:r>
-            <a:r>
-              <a:rPr lang="en-US" sz="6900" dirty="0" spc="11" kern="0">
-                <a:solidFill>
-                  <a:srgbClr val="14161C"/>
-                </a:solidFill>
-                <a:latin typeface="Bricolage Grotesque ExtraBold" pitchFamily="34" charset="0"/>
-                <a:ea typeface="Bricolage Grotesque ExtraBold" pitchFamily="34" charset="-122"/>
-                <a:cs typeface="Bricolage Grotesque ExtraBold" pitchFamily="34" charset="-120"/>
-              </a:rPr>
-              <a:t> đã</a:t>
-            </a:r>
-            <a:r>
-              <a:rPr lang="en-US" sz="6900" dirty="0" spc="0" kern="0">
-                <a:solidFill>
-                  <a:srgbClr val="14161C"/>
-                </a:solidFill>
-                <a:latin typeface="Bricolage Grotesque ExtraBold" pitchFamily="34" charset="0"/>
-                <a:ea typeface="Bricolage Grotesque ExtraBold" pitchFamily="34" charset="-122"/>
-                <a:cs typeface="Bricolage Grotesque ExtraBold" pitchFamily="34" charset="-120"/>
-              </a:rPr>
-              <a:t> sắp</a:t>
-            </a:r>
-            <a:r>
-              <a:rPr lang="en-US" sz="6900" dirty="0" spc="-79" kern="0">
-                <a:solidFill>
-                  <a:srgbClr val="14161C"/>
-                </a:solidFill>
-                <a:latin typeface="Bricolage Grotesque ExtraBold" pitchFamily="34" charset="0"/>
-                <a:ea typeface="Bricolage Grotesque ExtraBold" pitchFamily="34" charset="-122"/>
-                <a:cs typeface="Bricolage Grotesque ExtraBold" pitchFamily="34" charset="-120"/>
-              </a:rPr>
-              <a:t> xếp</a:t>
-            </a:r>
-            <a:r>
-              <a:rPr lang="en-US" sz="6900" dirty="0" spc="0" kern="0">
-                <a:solidFill>
-                  <a:srgbClr val="14161C"/>
-                </a:solidFill>
-                <a:latin typeface="Bricolage Grotesque ExtraBold" pitchFamily="34" charset="0"/>
-                <a:ea typeface="Bricolage Grotesque ExtraBold" pitchFamily="34" charset="-122"/>
-                <a:cs typeface="Bricolage Grotesque ExtraBold" pitchFamily="34" charset="-120"/>
-              </a:rPr>
-              <a:t> lại</a:t>
-            </a:r>
-            <a:endParaRPr lang="en-US" sz="6900" dirty="0"/>
-          </a:p>
-        </p:txBody>
-      </p:sp>
-      <p:sp>
-        <p:nvSpPr>
-          <p:cNvPr id="24" name="Connector line-1792422992425-979714611"/>
-          <p:cNvSpPr/>
-          <p:nvPr/>
-        </p:nvSpPr>
-        <p:spPr>
-          <a:xfrm>
-            <a:off x="1428750" y="4953000"/>
-            <a:ext cx="15430500" cy="0"/>
-          </a:xfrm>
-          <a:prstGeom prst="line">
-            <a:avLst/>
-          </a:prstGeom>
-          <a:noFill/>
-          <a:ln w="57150">
-            <a:solidFill>
-              <a:srgbClr val="14161C"/>
-            </a:solidFill>
-            <a:prstDash val="solid"/>
-            <a:headEnd type="none"/>
-            <a:tailEnd type="none"/>
-          </a:ln>
-        </p:spPr>
-      </p:sp>
-      <p:sp>
-        <p:nvSpPr>
-          <p:cNvPr id="25" name="Shape 23"/>
-          <p:cNvSpPr/>
-          <p:nvPr/>
-        </p:nvSpPr>
-        <p:spPr>
-          <a:xfrm>
-            <a:off x="2857500" y="4667250"/>
-            <a:ext cx="571500" cy="571500"/>
-          </a:xfrm>
-          <a:prstGeom prst="ellipse">
-            <a:avLst/>
-          </a:prstGeom>
-          <a:solidFill>
-            <a:srgbClr val="B45309"/>
-          </a:solidFill>
-          <a:ln/>
-        </p:spPr>
-      </p:sp>
-      <p:sp>
-        <p:nvSpPr>
-          <p:cNvPr id="26" name="Shape 24"/>
-          <p:cNvSpPr/>
-          <p:nvPr/>
-        </p:nvSpPr>
-        <p:spPr>
-          <a:xfrm>
-            <a:off x="8858250" y="4667250"/>
-            <a:ext cx="571500" cy="571500"/>
-          </a:xfrm>
-          <a:prstGeom prst="ellipse">
-            <a:avLst/>
-          </a:prstGeom>
-          <a:solidFill>
-            <a:srgbClr val="B45309"/>
-          </a:solidFill>
-          <a:ln/>
-        </p:spPr>
-      </p:sp>
-      <p:sp>
-        <p:nvSpPr>
-          <p:cNvPr id="27" name="Shape 25"/>
-          <p:cNvSpPr/>
-          <p:nvPr/>
-        </p:nvSpPr>
-        <p:spPr>
-          <a:xfrm>
-            <a:off x="14859000" y="4667250"/>
-            <a:ext cx="571500" cy="571500"/>
-          </a:xfrm>
-          <a:prstGeom prst="ellipse">
-            <a:avLst/>
-          </a:prstGeom>
-          <a:solidFill>
-            <a:srgbClr val="B45309"/>
-          </a:solidFill>
-          <a:ln/>
-        </p:spPr>
-      </p:sp>
-      <p:sp>
-        <p:nvSpPr>
-          <p:cNvPr id="28" name="Text 26"/>
-          <p:cNvSpPr/>
-          <p:nvPr/>
-        </p:nvSpPr>
-        <p:spPr>
-          <a:xfrm>
-            <a:off x="904875" y="5619750"/>
-            <a:ext cx="4476750" cy="1905000"/>
-          </a:xfrm>
-          <a:prstGeom prst="rect">
-            <a:avLst/>
-          </a:prstGeom>
-          <a:noFill/>
-          <a:ln/>
-        </p:spPr>
-        <p:txBody>
-          <a:bodyPr wrap="square" lIns="0" tIns="12954" rIns="0" bIns="-12954" rtlCol="0" anchor="t"/>
-          <a:lstStyle/>
-          <a:p>
-            <a:pPr algn="ctr" indent="0" marL="0">
-              <a:lnSpc>
-                <a:spcPts val="3120"/>
-              </a:lnSpc>
-              <a:buNone/>
-            </a:pPr>
-            <a:r>
-              <a:rPr lang="en-US" sz="2400" b="1" dirty="0" spc="0" kern="0">
-                <a:solidFill>
-                  <a:srgbClr val="14161C"/>
-                </a:solidFill>
-                <a:latin typeface="Be Vietnam Pro" pitchFamily="34" charset="0"/>
-                <a:ea typeface="Be Vietnam Pro" pitchFamily="34" charset="-122"/>
-                <a:cs typeface="Be Vietnam Pro" pitchFamily="34" charset="-120"/>
-              </a:rPr>
-              <a:t>Giữ</a:t>
-            </a:r>
-            <a:r>
-              <a:rPr lang="en-US" sz="2400" b="1" dirty="0" spc="1" kern="0">
-                <a:solidFill>
-                  <a:srgbClr val="14161C"/>
-                </a:solidFill>
-                <a:latin typeface="Be Vietnam Pro" pitchFamily="34" charset="0"/>
-                <a:ea typeface="Be Vietnam Pro" pitchFamily="34" charset="-122"/>
-                <a:cs typeface="Be Vietnam Pro" pitchFamily="34" charset="-120"/>
-              </a:rPr>
-              <a:t> thứ</a:t>
-            </a:r>
-            <a:r>
-              <a:rPr lang="en-US" sz="2400" b="1" dirty="0" spc="3" kern="0">
-                <a:solidFill>
-                  <a:srgbClr val="14161C"/>
-                </a:solidFill>
-                <a:latin typeface="Be Vietnam Pro" pitchFamily="34" charset="0"/>
-                <a:ea typeface="Be Vietnam Pro" pitchFamily="34" charset="-122"/>
-                <a:cs typeface="Be Vietnam Pro" pitchFamily="34" charset="-120"/>
-              </a:rPr>
-              <a:t> tự</a:t>
-            </a:r>
-            <a:r>
-              <a:rPr lang="en-US" sz="2400" b="1" dirty="0" spc="2" kern="0">
-                <a:solidFill>
-                  <a:srgbClr val="14161C"/>
-                </a:solidFill>
-                <a:latin typeface="Be Vietnam Pro" pitchFamily="34" charset="0"/>
-                <a:ea typeface="Be Vietnam Pro" pitchFamily="34" charset="-122"/>
-                <a:cs typeface="Be Vietnam Pro" pitchFamily="34" charset="-120"/>
-              </a:rPr>
-              <a:t> sáu</a:t>
-            </a:r>
-            <a:r>
-              <a:rPr lang="en-US" sz="2400" b="1" dirty="0" spc="11" kern="0">
-                <a:solidFill>
-                  <a:srgbClr val="14161C"/>
-                </a:solidFill>
-                <a:latin typeface="Be Vietnam Pro" pitchFamily="34" charset="0"/>
-                <a:ea typeface="Be Vietnam Pro" pitchFamily="34" charset="-122"/>
-                <a:cs typeface="Be Vietnam Pro" pitchFamily="34" charset="-120"/>
-              </a:rPr>
-              <a:t> bước</a:t>
-            </a:r>
-            <a:r>
-              <a:rPr lang="en-US" sz="2400" b="1" dirty="0" spc="2" kern="0">
-                <a:solidFill>
-                  <a:srgbClr val="14161C"/>
-                </a:solidFill>
-                <a:latin typeface="Be Vietnam Pro" pitchFamily="34" charset="0"/>
-                <a:ea typeface="Be Vietnam Pro" pitchFamily="34" charset="-122"/>
-                <a:cs typeface="Be Vietnam Pro" pitchFamily="34" charset="-120"/>
-              </a:rPr>
-              <a:t> của</a:t>
-            </a:r>
-            <a:r>
-              <a:rPr lang="en-US" sz="2400" b="1" dirty="0" spc="0" kern="0">
-                <a:solidFill>
-                  <a:srgbClr val="14161C"/>
-                </a:solidFill>
-                <a:latin typeface="Be Vietnam Pro" pitchFamily="34" charset="0"/>
-                <a:ea typeface="Be Vietnam Pro" pitchFamily="34" charset="-122"/>
-                <a:cs typeface="Be Vietnam Pro" pitchFamily="34" charset="-120"/>
-              </a:rPr>
-              <a:t> bài</a:t>
-            </a:r>
-            <a:r>
-              <a:rPr lang="en-US" sz="2400" b="1" dirty="0" spc="-6" kern="0">
-                <a:solidFill>
-                  <a:srgbClr val="14161C"/>
-                </a:solidFill>
-                <a:latin typeface="Be Vietnam Pro" pitchFamily="34" charset="0"/>
-                <a:ea typeface="Be Vietnam Pro" pitchFamily="34" charset="-122"/>
-                <a:cs typeface="Be Vietnam Pro" pitchFamily="34" charset="-120"/>
-              </a:rPr>
-              <a:t> nguồn</a:t>
-            </a:r>
-            <a:endParaRPr lang="en-US" sz="2400" dirty="0"/>
-          </a:p>
-        </p:txBody>
-      </p:sp>
-      <p:sp>
-        <p:nvSpPr>
-          <p:cNvPr id="29" name="Text 27"/>
-          <p:cNvSpPr/>
-          <p:nvPr/>
-        </p:nvSpPr>
-        <p:spPr>
-          <a:xfrm>
-            <a:off x="6905625" y="5619750"/>
-            <a:ext cx="4476750" cy="1905000"/>
-          </a:xfrm>
-          <a:prstGeom prst="rect">
-            <a:avLst/>
-          </a:prstGeom>
-          <a:noFill/>
-          <a:ln/>
-        </p:spPr>
-        <p:txBody>
-          <a:bodyPr wrap="square" lIns="0" tIns="12954" rIns="0" bIns="-12954" rtlCol="0" anchor="t"/>
-          <a:lstStyle/>
-          <a:p>
-            <a:pPr algn="ctr" indent="0" marL="0">
-              <a:lnSpc>
-                <a:spcPts val="3120"/>
-              </a:lnSpc>
-              <a:buNone/>
-            </a:pPr>
-            <a:r>
-              <a:rPr lang="en-US" sz="2400" b="1" dirty="0" spc="-5" kern="0">
-                <a:solidFill>
-                  <a:srgbClr val="14161C"/>
-                </a:solidFill>
-                <a:latin typeface="Be Vietnam Pro" pitchFamily="34" charset="0"/>
-                <a:ea typeface="Be Vietnam Pro" pitchFamily="34" charset="-122"/>
-                <a:cs typeface="Be Vietnam Pro" pitchFamily="34" charset="-120"/>
-              </a:rPr>
-              <a:t>Gom</a:t>
-            </a:r>
-            <a:r>
-              <a:rPr lang="en-US" sz="2400" b="1" dirty="0" spc="-1" kern="0">
-                <a:solidFill>
-                  <a:srgbClr val="14161C"/>
-                </a:solidFill>
-                <a:latin typeface="Be Vietnam Pro" pitchFamily="34" charset="0"/>
-                <a:ea typeface="Be Vietnam Pro" pitchFamily="34" charset="-122"/>
-                <a:cs typeface="Be Vietnam Pro" pitchFamily="34" charset="-120"/>
-              </a:rPr>
-              <a:t> thành</a:t>
-            </a:r>
-            <a:r>
-              <a:rPr lang="en-US" sz="2400" b="1" dirty="0" spc="-2" kern="0">
-                <a:solidFill>
-                  <a:srgbClr val="14161C"/>
-                </a:solidFill>
-                <a:latin typeface="Be Vietnam Pro" pitchFamily="34" charset="0"/>
-                <a:ea typeface="Be Vietnam Pro" pitchFamily="34" charset="-122"/>
-                <a:cs typeface="Be Vietnam Pro" pitchFamily="34" charset="-120"/>
-              </a:rPr>
-              <a:t> hai</a:t>
-            </a:r>
-            <a:r>
-              <a:rPr lang="en-US" sz="2400" b="1" dirty="0" spc="-6" kern="0">
-                <a:solidFill>
-                  <a:srgbClr val="14161C"/>
-                </a:solidFill>
-                <a:latin typeface="Be Vietnam Pro" pitchFamily="34" charset="0"/>
-                <a:ea typeface="Be Vietnam Pro" pitchFamily="34" charset="-122"/>
-                <a:cs typeface="Be Vietnam Pro" pitchFamily="34" charset="-120"/>
-              </a:rPr>
-              <a:t> nhóm</a:t>
-            </a:r>
-            <a:r>
-              <a:rPr lang="en-US" sz="2400" b="1" dirty="0" spc="0" kern="0">
-                <a:solidFill>
-                  <a:srgbClr val="14161C"/>
-                </a:solidFill>
-                <a:latin typeface="Be Vietnam Pro" pitchFamily="34" charset="0"/>
-                <a:ea typeface="Be Vietnam Pro" pitchFamily="34" charset="-122"/>
-                <a:cs typeface="Be Vietnam Pro" pitchFamily="34" charset="-120"/>
-              </a:rPr>
-              <a:t> ba</a:t>
-            </a:r>
-            <a:r>
-              <a:rPr lang="en-US" sz="2400" b="1" dirty="0" spc="10" kern="0">
-                <a:solidFill>
-                  <a:srgbClr val="14161C"/>
-                </a:solidFill>
-                <a:latin typeface="Be Vietnam Pro" pitchFamily="34" charset="0"/>
-                <a:ea typeface="Be Vietnam Pro" pitchFamily="34" charset="-122"/>
-                <a:cs typeface="Be Vietnam Pro" pitchFamily="34" charset="-120"/>
-              </a:rPr>
-              <a:t> bước</a:t>
-            </a:r>
-            <a:endParaRPr lang="en-US" sz="2400" dirty="0"/>
-          </a:p>
-        </p:txBody>
-      </p:sp>
-      <p:sp>
-        <p:nvSpPr>
-          <p:cNvPr id="30" name="Text 28"/>
-          <p:cNvSpPr/>
-          <p:nvPr/>
-        </p:nvSpPr>
-        <p:spPr>
-          <a:xfrm>
-            <a:off x="12906375" y="5619750"/>
-            <a:ext cx="4476750" cy="1905000"/>
-          </a:xfrm>
-          <a:prstGeom prst="rect">
-            <a:avLst/>
-          </a:prstGeom>
-          <a:noFill/>
-          <a:ln/>
-        </p:spPr>
-        <p:txBody>
-          <a:bodyPr wrap="square" lIns="0" tIns="12954" rIns="0" bIns="-12954" rtlCol="0" anchor="t"/>
-          <a:lstStyle/>
-          <a:p>
-            <a:pPr algn="ctr" indent="0" marL="0">
-              <a:lnSpc>
-                <a:spcPts val="3120"/>
-              </a:lnSpc>
-              <a:buNone/>
-            </a:pPr>
-            <a:r>
-              <a:rPr lang="en-US" sz="2400" b="1" dirty="0" spc="-10" kern="0">
-                <a:solidFill>
-                  <a:srgbClr val="14161C"/>
-                </a:solidFill>
-                <a:latin typeface="Be Vietnam Pro" pitchFamily="34" charset="0"/>
-                <a:ea typeface="Be Vietnam Pro" pitchFamily="34" charset="-122"/>
-                <a:cs typeface="Be Vietnam Pro" pitchFamily="34" charset="-120"/>
-              </a:rPr>
-              <a:t>Thêm</a:t>
-            </a:r>
-            <a:r>
-              <a:rPr lang="en-US" sz="2400" b="1" dirty="0" spc="1" kern="0">
-                <a:solidFill>
-                  <a:srgbClr val="14161C"/>
-                </a:solidFill>
-                <a:latin typeface="Be Vietnam Pro" pitchFamily="34" charset="0"/>
-                <a:ea typeface="Be Vietnam Pro" pitchFamily="34" charset="-122"/>
-                <a:cs typeface="Be Vietnam Pro" pitchFamily="34" charset="-120"/>
-              </a:rPr>
-              <a:t> ví</a:t>
-            </a:r>
-            <a:r>
-              <a:rPr lang="en-US" sz="2400" b="1" dirty="0" spc="3" kern="0">
-                <a:solidFill>
-                  <a:srgbClr val="14161C"/>
-                </a:solidFill>
-                <a:latin typeface="Be Vietnam Pro" pitchFamily="34" charset="0"/>
-                <a:ea typeface="Be Vietnam Pro" pitchFamily="34" charset="-122"/>
-                <a:cs typeface="Be Vietnam Pro" pitchFamily="34" charset="-120"/>
-              </a:rPr>
-              <a:t> dụ</a:t>
-            </a:r>
-            <a:r>
-              <a:rPr lang="en-US" sz="2400" b="1" dirty="0" spc="0" kern="0">
-                <a:solidFill>
-                  <a:srgbClr val="14161C"/>
-                </a:solidFill>
-                <a:latin typeface="Be Vietnam Pro" pitchFamily="34" charset="0"/>
-                <a:ea typeface="Be Vietnam Pro" pitchFamily="34" charset="-122"/>
-                <a:cs typeface="Be Vietnam Pro" pitchFamily="34" charset="-120"/>
-              </a:rPr>
-              <a:t> tính</a:t>
-            </a:r>
-            <a:r>
-              <a:rPr lang="en-US" sz="2400" b="1" dirty="0" spc="-19" kern="0">
-                <a:solidFill>
-                  <a:srgbClr val="14161C"/>
-                </a:solidFill>
-                <a:latin typeface="Be Vietnam Pro" pitchFamily="34" charset="0"/>
-                <a:ea typeface="Be Vietnam Pro" pitchFamily="34" charset="-122"/>
-                <a:cs typeface="Be Vietnam Pro" pitchFamily="34" charset="-120"/>
-              </a:rPr>
-              <a:t> và</a:t>
-            </a:r>
-            <a:r>
-              <a:rPr lang="en-US" sz="2400" b="1" dirty="0" spc="32" kern="0">
-                <a:solidFill>
-                  <a:srgbClr val="14161C"/>
-                </a:solidFill>
-                <a:latin typeface="Be Vietnam Pro" pitchFamily="34" charset="0"/>
-                <a:ea typeface="Be Vietnam Pro" pitchFamily="34" charset="-122"/>
-                <a:cs typeface="Be Vietnam Pro" pitchFamily="34" charset="-120"/>
-              </a:rPr>
-              <a:t> lưu</a:t>
-            </a:r>
-            <a:r>
-              <a:rPr lang="en-US" sz="2400" b="1" dirty="0" spc="-1" kern="0">
-                <a:solidFill>
-                  <a:srgbClr val="14161C"/>
-                </a:solidFill>
-                <a:latin typeface="Be Vietnam Pro" pitchFamily="34" charset="0"/>
-                <a:ea typeface="Be Vietnam Pro" pitchFamily="34" charset="-122"/>
-                <a:cs typeface="Be Vietnam Pro" pitchFamily="34" charset="-120"/>
-              </a:rPr>
-              <a:t> ý</a:t>
-            </a:r>
-            <a:r>
-              <a:rPr lang="en-US" sz="2400" b="1" dirty="0" spc="1" kern="0">
-                <a:solidFill>
-                  <a:srgbClr val="14161C"/>
-                </a:solidFill>
-                <a:latin typeface="Be Vietnam Pro" pitchFamily="34" charset="0"/>
-                <a:ea typeface="Be Vietnam Pro" pitchFamily="34" charset="-122"/>
-                <a:cs typeface="Be Vietnam Pro" pitchFamily="34" charset="-120"/>
-              </a:rPr>
-              <a:t> bản</a:t>
-            </a:r>
-            <a:r>
-              <a:rPr lang="en-US" sz="2400" b="1" dirty="0" spc="4" kern="0">
-                <a:solidFill>
-                  <a:srgbClr val="14161C"/>
-                </a:solidFill>
-                <a:latin typeface="Be Vietnam Pro" pitchFamily="34" charset="0"/>
-                <a:ea typeface="Be Vietnam Pro" pitchFamily="34" charset="-122"/>
-                <a:cs typeface="Be Vietnam Pro" pitchFamily="34" charset="-120"/>
-              </a:rPr>
-              <a:t> sao</a:t>
-            </a:r>
-            <a:endParaRPr lang="en-US" sz="2400" dirty="0"/>
-          </a:p>
-        </p:txBody>
-      </p:sp>
-      <p:sp>
-        <p:nvSpPr>
-          <p:cNvPr id="31" name="Shape 29"/>
-          <p:cNvSpPr/>
-          <p:nvPr/>
-        </p:nvSpPr>
-        <p:spPr>
-          <a:xfrm>
-            <a:off x="933450" y="9429750"/>
-            <a:ext cx="114300" cy="114300"/>
-          </a:xfrm>
-          <a:prstGeom prst="ellipse">
-            <a:avLst/>
-          </a:prstGeom>
-          <a:solidFill>
-            <a:srgbClr val="14161C"/>
-          </a:solidFill>
-          <a:ln w="19050">
-            <a:solidFill>
-              <a:srgbClr val="14161C"/>
-            </a:solidFill>
-            <a:prstDash val="solid"/>
-          </a:ln>
-        </p:spPr>
-      </p:sp>
-      <p:sp>
-        <p:nvSpPr>
-          <p:cNvPr id="32" name="Shape 30"/>
-          <p:cNvSpPr/>
-          <p:nvPr/>
-        </p:nvSpPr>
-        <p:spPr>
-          <a:xfrm>
-            <a:off x="1257300" y="9429750"/>
-            <a:ext cx="114300" cy="114300"/>
-          </a:xfrm>
-          <a:prstGeom prst="ellipse">
-            <a:avLst/>
-          </a:prstGeom>
-          <a:solidFill>
-            <a:srgbClr val="14161C"/>
-          </a:solidFill>
-          <a:ln w="19050">
-            <a:solidFill>
-              <a:srgbClr val="14161C"/>
-            </a:solidFill>
-            <a:prstDash val="solid"/>
-          </a:ln>
-        </p:spPr>
-      </p:sp>
-      <p:sp>
-        <p:nvSpPr>
-          <p:cNvPr id="33" name="Shape 31"/>
-          <p:cNvSpPr/>
-          <p:nvPr/>
-        </p:nvSpPr>
-        <p:spPr>
-          <a:xfrm>
-            <a:off x="1581150" y="9429750"/>
-            <a:ext cx="114300" cy="114300"/>
-          </a:xfrm>
-          <a:prstGeom prst="ellipse">
-            <a:avLst/>
-          </a:prstGeom>
-          <a:solidFill>
-            <a:srgbClr val="14161C"/>
-          </a:solidFill>
-          <a:ln w="19050">
-            <a:solidFill>
-              <a:srgbClr val="14161C"/>
-            </a:solidFill>
-            <a:prstDash val="solid"/>
-          </a:ln>
-        </p:spPr>
-      </p:sp>
-      <p:sp>
-        <p:nvSpPr>
-          <p:cNvPr id="34" name="Shape 32"/>
-          <p:cNvSpPr/>
-          <p:nvPr/>
-        </p:nvSpPr>
-        <p:spPr>
-          <a:xfrm>
-            <a:off x="1905000" y="9429750"/>
-            <a:ext cx="114300" cy="114300"/>
-          </a:xfrm>
-          <a:prstGeom prst="ellipse">
-            <a:avLst/>
-          </a:prstGeom>
-          <a:solidFill>
-            <a:srgbClr val="14161C"/>
-          </a:solidFill>
-          <a:ln w="19050">
-            <a:solidFill>
-              <a:srgbClr val="14161C"/>
-            </a:solidFill>
-            <a:prstDash val="solid"/>
-          </a:ln>
-        </p:spPr>
-      </p:sp>
-      <p:sp>
-        <p:nvSpPr>
-          <p:cNvPr id="35" name="Shape 33"/>
-          <p:cNvSpPr/>
-          <p:nvPr/>
-        </p:nvSpPr>
-        <p:spPr>
-          <a:xfrm>
-            <a:off x="2228850" y="9429750"/>
-            <a:ext cx="114300" cy="114300"/>
-          </a:xfrm>
-          <a:prstGeom prst="ellipse">
-            <a:avLst/>
-          </a:prstGeom>
-          <a:solidFill>
-            <a:srgbClr val="14161C"/>
-          </a:solidFill>
-          <a:ln w="19050">
-            <a:solidFill>
-              <a:srgbClr val="14161C"/>
-            </a:solidFill>
-            <a:prstDash val="solid"/>
-          </a:ln>
-        </p:spPr>
-      </p:sp>
-      <p:sp>
-        <p:nvSpPr>
-          <p:cNvPr id="36" name="Shape 34"/>
-          <p:cNvSpPr/>
-          <p:nvPr/>
-        </p:nvSpPr>
-        <p:spPr>
-          <a:xfrm>
-            <a:off x="2552700" y="9429750"/>
-            <a:ext cx="114300" cy="114300"/>
-          </a:xfrm>
-          <a:prstGeom prst="ellipse">
-            <a:avLst/>
-          </a:prstGeom>
-          <a:solidFill>
-            <a:srgbClr val="14161C"/>
-          </a:solidFill>
-          <a:ln w="19050">
-            <a:solidFill>
-              <a:srgbClr val="14161C"/>
-            </a:solidFill>
-            <a:prstDash val="solid"/>
-          </a:ln>
-        </p:spPr>
-      </p:sp>
-      <p:sp>
-        <p:nvSpPr>
-          <p:cNvPr id="37" name="Shape 35"/>
-          <p:cNvSpPr/>
-          <p:nvPr/>
-        </p:nvSpPr>
-        <p:spPr>
-          <a:xfrm>
-            <a:off x="2876550" y="9429750"/>
-            <a:ext cx="114300" cy="114300"/>
-          </a:xfrm>
-          <a:prstGeom prst="ellipse">
-            <a:avLst/>
-          </a:prstGeom>
-          <a:solidFill>
-            <a:srgbClr val="14161C"/>
-          </a:solidFill>
-          <a:ln w="19050">
-            <a:solidFill>
-              <a:srgbClr val="14161C"/>
-            </a:solidFill>
-            <a:prstDash val="solid"/>
-          </a:ln>
-        </p:spPr>
-      </p:sp>
-      <p:sp>
-        <p:nvSpPr>
-          <p:cNvPr id="38" name="Shape 36"/>
-          <p:cNvSpPr/>
-          <p:nvPr/>
-        </p:nvSpPr>
-        <p:spPr>
-          <a:xfrm>
-            <a:off x="3200400" y="9429750"/>
-            <a:ext cx="114300" cy="114300"/>
-          </a:xfrm>
-          <a:prstGeom prst="ellipse">
-            <a:avLst/>
-          </a:prstGeom>
-          <a:solidFill>
-            <a:srgbClr val="14161C"/>
-          </a:solidFill>
-          <a:ln w="19050">
-            <a:solidFill>
-              <a:srgbClr val="14161C"/>
-            </a:solidFill>
-            <a:prstDash val="solid"/>
-          </a:ln>
-        </p:spPr>
-      </p:sp>
-      <p:sp>
-        <p:nvSpPr>
-          <p:cNvPr id="39" name="Shape 37"/>
-          <p:cNvSpPr/>
-          <p:nvPr/>
-        </p:nvSpPr>
-        <p:spPr>
-          <a:xfrm>
-            <a:off x="3486150" y="9391650"/>
-            <a:ext cx="190500" cy="190500"/>
-          </a:xfrm>
-          <a:prstGeom prst="ellipse">
-            <a:avLst/>
-          </a:prstGeom>
-          <a:solidFill>
-            <a:srgbClr val="FF6A4D"/>
-          </a:solidFill>
-          <a:ln w="19050">
-            <a:solidFill>
-              <a:srgbClr val="FF6A4D"/>
-            </a:solidFill>
-            <a:prstDash val="solid"/>
-          </a:ln>
-        </p:spPr>
-      </p:sp>
-      <p:sp>
-        <p:nvSpPr>
-          <p:cNvPr id="40" name="Shape 38"/>
-          <p:cNvSpPr/>
-          <p:nvPr/>
-        </p:nvSpPr>
-        <p:spPr>
-          <a:xfrm>
-            <a:off x="3848100" y="9429750"/>
-            <a:ext cx="114300" cy="114300"/>
-          </a:xfrm>
-          <a:prstGeom prst="ellipse">
-            <a:avLst/>
-          </a:prstGeom>
-          <a:solidFill>
-            <a:srgbClr val="F3EEE3"/>
-          </a:solidFill>
-          <a:ln w="19050">
-            <a:solidFill>
-              <a:srgbClr val="8A867C"/>
-            </a:solidFill>
-            <a:prstDash val="solid"/>
-          </a:ln>
-        </p:spPr>
-      </p:sp>
-      <p:sp>
-        <p:nvSpPr>
-          <p:cNvPr id="41" name="Text 39"/>
-          <p:cNvSpPr/>
-          <p:nvPr/>
-        </p:nvSpPr>
-        <p:spPr>
-          <a:xfrm>
-            <a:off x="914400" y="9715500"/>
-            <a:ext cx="6667500" cy="285750"/>
-          </a:xfrm>
-          <a:prstGeom prst="rect">
-            <a:avLst/>
-          </a:prstGeom>
-          <a:noFill/>
-          <a:ln/>
-        </p:spPr>
-        <p:txBody>
-          <a:bodyPr wrap="square" lIns="0" tIns="0" rIns="0" bIns="0" rtlCol="0" anchor="t"/>
-          <a:lstStyle/>
-          <a:p>
-            <a:pPr algn="l" indent="0" marL="0">
-              <a:buNone/>
-            </a:pPr>
-            <a:r>
-              <a:rPr lang="en-US" sz="1650" dirty="0" spc="-12" kern="0">
-                <a:solidFill>
-                  <a:srgbClr val="6B6A66"/>
-                </a:solidFill>
-                <a:latin typeface="Be Vietnam Pro" pitchFamily="34" charset="0"/>
-                <a:ea typeface="Be Vietnam Pro" pitchFamily="34" charset="-122"/>
-                <a:cs typeface="Be Vietnam Pro" pitchFamily="34" charset="-120"/>
-              </a:rPr>
-              <a:t>System</a:t>
-            </a:r>
-            <a:r>
-              <a:rPr lang="en-US" sz="1650" dirty="0" spc="0" kern="0">
-                <a:solidFill>
-                  <a:srgbClr val="6B6A66"/>
-                </a:solidFill>
-                <a:latin typeface="Be Vietnam Pro" pitchFamily="34" charset="0"/>
-                <a:ea typeface="Be Vietnam Pro" pitchFamily="34" charset="-122"/>
-                <a:cs typeface="Be Vietnam Pro" pitchFamily="34" charset="-120"/>
-              </a:rPr>
-              <a:t> Design</a:t>
-            </a:r>
-            <a:r>
-              <a:rPr lang="en-US" sz="1650" dirty="0" spc="1" kern="0">
-                <a:solidFill>
-                  <a:srgbClr val="6B6A66"/>
-                </a:solidFill>
-                <a:latin typeface="Be Vietnam Pro" pitchFamily="34" charset="0"/>
-                <a:ea typeface="Be Vietnam Pro" pitchFamily="34" charset="-122"/>
-                <a:cs typeface="Be Vietnam Pro" pitchFamily="34" charset="-120"/>
-              </a:rPr>
-              <a:t> 101</a:t>
-            </a:r>
-            <a:r>
-              <a:rPr lang="en-US" sz="1650" dirty="0" spc="0" kern="0">
-                <a:solidFill>
-                  <a:srgbClr val="6B6A66"/>
-                </a:solidFill>
-                <a:latin typeface="Be Vietnam Pro" pitchFamily="34" charset="0"/>
-                <a:ea typeface="Be Vietnam Pro" pitchFamily="34" charset="-122"/>
-                <a:cs typeface="Be Vietnam Pro" pitchFamily="34" charset="-120"/>
-              </a:rPr>
-              <a:t> ·</a:t>
-            </a:r>
-            <a:r>
-              <a:rPr lang="en-US" sz="1650" dirty="0" spc="1" kern="0">
-                <a:solidFill>
-                  <a:srgbClr val="6B6A66"/>
-                </a:solidFill>
-                <a:latin typeface="Be Vietnam Pro" pitchFamily="34" charset="0"/>
-                <a:ea typeface="Be Vietnam Pro" pitchFamily="34" charset="-122"/>
-                <a:cs typeface="Be Vietnam Pro" pitchFamily="34" charset="-120"/>
-              </a:rPr>
-              <a:t> Bài 13 ·</a:t>
-            </a:r>
-            <a:r>
-              <a:rPr lang="en-US" sz="1650" dirty="0" spc="2" kern="0">
-                <a:solidFill>
-                  <a:srgbClr val="6B6A66"/>
-                </a:solidFill>
-                <a:latin typeface="Be Vietnam Pro" pitchFamily="34" charset="0"/>
-                <a:ea typeface="Be Vietnam Pro" pitchFamily="34" charset="-122"/>
-                <a:cs typeface="Be Vietnam Pro" pitchFamily="34" charset="-120"/>
-              </a:rPr>
-              <a:t> 09/10</a:t>
-            </a:r>
-            <a:endParaRPr lang="en-US" sz="1650" dirty="0"/>
-          </a:p>
-        </p:txBody>
-      </p:sp>
-      <p:sp>
-        <p:nvSpPr>
-          <p:cNvPr id="42" name="Shape 40"/>
+          <p:cNvPr id="22" name="Shape 20"/>
           <p:cNvSpPr/>
           <p:nvPr/>
         </p:nvSpPr>
@@ -13196,7 +12340,7 @@
       </p:sp>
       <p:pic>
         <p:nvPicPr>
-          <p:cNvPr id="43" name="Moda image moda-export-watermark-65d7b914-beef-4e83-a63f-0a76c76d7688" descr="">    </p:cNvPr>
+          <p:cNvPr id="23" name="Moda image moda-export-watermark-65d7b914-beef-4e83-a63f-0a76c76d7688" descr="">    </p:cNvPr>
           <p:cNvPicPr>
             <a:picLocks noChangeAspect="1"/>
           </p:cNvPicPr>

</xml_diff>